<commit_message>
Add IAM and LB ppt by harsha
</commit_message>
<xml_diff>
--- a/IAM and LB.pptx
+++ b/IAM and LB.pptx
@@ -653,7 +653,7 @@
           <a:p>
             <a:fld id="{5BCAD085-E8A6-8845-BD4E-CB4CCA059FC4}" type="datetimeFigureOut">
               <a:rPr lang="en-US" smtClean="0"/>
-              <a:t>7/14/2025</a:t>
+              <a:t>9/2/2025</a:t>
             </a:fld>
             <a:endParaRPr lang="en-US"/>
           </a:p>
@@ -754,7 +754,7 @@
           </a:ln>
           <a:extLst>
             <a:ext uri="{91240B29-F687-4f45-9708-019B960494DF}">
-              <a14:hiddenLine xmlns="" xmlns:a14="http://schemas.microsoft.com/office/drawing/2010/main" w="9525">
+              <a14:hiddenLine xmlns:a14="http://schemas.microsoft.com/office/drawing/2010/main" xmlns="" w="9525">
                 <a:solidFill>
                   <a:srgbClr val="000000"/>
                 </a:solidFill>
@@ -809,7 +809,7 @@
           </a:ln>
           <a:extLst>
             <a:ext uri="{91240B29-F687-4f45-9708-019B960494DF}">
-              <a14:hiddenLine xmlns="" xmlns:a14="http://schemas.microsoft.com/office/drawing/2010/main" w="9525">
+              <a14:hiddenLine xmlns:a14="http://schemas.microsoft.com/office/drawing/2010/main" xmlns="" w="9525">
                 <a:solidFill>
                   <a:srgbClr val="000000"/>
                 </a:solidFill>
@@ -1064,7 +1064,7 @@
           <a:p>
             <a:fld id="{5BCAD085-E8A6-8845-BD4E-CB4CCA059FC4}" type="datetimeFigureOut">
               <a:rPr lang="en-US" smtClean="0"/>
-              <a:t>7/14/2025</a:t>
+              <a:t>9/2/2025</a:t>
             </a:fld>
             <a:endParaRPr lang="en-US"/>
           </a:p>
@@ -1312,7 +1312,7 @@
           <a:p>
             <a:fld id="{5BCAD085-E8A6-8845-BD4E-CB4CCA059FC4}" type="datetimeFigureOut">
               <a:rPr lang="en-US" smtClean="0"/>
-              <a:t>7/14/2025</a:t>
+              <a:t>9/2/2025</a:t>
             </a:fld>
             <a:endParaRPr lang="en-US"/>
           </a:p>
@@ -1852,7 +1852,7 @@
           <a:p>
             <a:fld id="{5BCAD085-E8A6-8845-BD4E-CB4CCA059FC4}" type="datetimeFigureOut">
               <a:rPr lang="en-US" smtClean="0"/>
-              <a:t>7/14/2025</a:t>
+              <a:t>9/2/2025</a:t>
             </a:fld>
             <a:endParaRPr lang="en-US"/>
           </a:p>
@@ -2100,7 +2100,7 @@
           <a:p>
             <a:fld id="{5BCAD085-E8A6-8845-BD4E-CB4CCA059FC4}" type="datetimeFigureOut">
               <a:rPr lang="en-US" smtClean="0"/>
-              <a:t>7/14/2025</a:t>
+              <a:t>9/2/2025</a:t>
             </a:fld>
             <a:endParaRPr lang="en-US"/>
           </a:p>
@@ -2632,7 +2632,7 @@
           <a:p>
             <a:fld id="{5BCAD085-E8A6-8845-BD4E-CB4CCA059FC4}" type="datetimeFigureOut">
               <a:rPr lang="en-US" smtClean="0"/>
-              <a:t>7/14/2025</a:t>
+              <a:t>9/2/2025</a:t>
             </a:fld>
             <a:endParaRPr lang="en-US"/>
           </a:p>
@@ -2929,7 +2929,7 @@
           <a:p>
             <a:fld id="{5BCAD085-E8A6-8845-BD4E-CB4CCA059FC4}" type="datetimeFigureOut">
               <a:rPr lang="en-US" smtClean="0"/>
-              <a:t>7/14/2025</a:t>
+              <a:t>9/2/2025</a:t>
             </a:fld>
             <a:endParaRPr lang="en-US"/>
           </a:p>
@@ -3103,7 +3103,7 @@
           <a:p>
             <a:fld id="{5BCAD085-E8A6-8845-BD4E-CB4CCA059FC4}" type="datetimeFigureOut">
               <a:rPr lang="en-US" smtClean="0"/>
-              <a:t>7/14/2025</a:t>
+              <a:t>9/2/2025</a:t>
             </a:fld>
             <a:endParaRPr lang="en-US"/>
           </a:p>
@@ -3283,7 +3283,7 @@
           <a:p>
             <a:fld id="{5BCAD085-E8A6-8845-BD4E-CB4CCA059FC4}" type="datetimeFigureOut">
               <a:rPr lang="en-US" smtClean="0"/>
-              <a:t>7/14/2025</a:t>
+              <a:t>9/2/2025</a:t>
             </a:fld>
             <a:endParaRPr lang="en-US"/>
           </a:p>
@@ -3468,7 +3468,7 @@
           <a:p>
             <a:fld id="{5BCAD085-E8A6-8845-BD4E-CB4CCA059FC4}" type="datetimeFigureOut">
               <a:rPr lang="en-US" smtClean="0"/>
-              <a:t>7/14/2025</a:t>
+              <a:t>9/2/2025</a:t>
             </a:fld>
             <a:endParaRPr lang="en-US"/>
           </a:p>
@@ -3724,7 +3724,7 @@
           <a:p>
             <a:fld id="{5BCAD085-E8A6-8845-BD4E-CB4CCA059FC4}" type="datetimeFigureOut">
               <a:rPr lang="en-US" smtClean="0"/>
-              <a:t>7/14/2025</a:t>
+              <a:t>9/2/2025</a:t>
             </a:fld>
             <a:endParaRPr lang="en-US"/>
           </a:p>
@@ -4026,7 +4026,7 @@
           <a:p>
             <a:fld id="{5BCAD085-E8A6-8845-BD4E-CB4CCA059FC4}" type="datetimeFigureOut">
               <a:rPr lang="en-US" smtClean="0"/>
-              <a:t>7/14/2025</a:t>
+              <a:t>9/2/2025</a:t>
             </a:fld>
             <a:endParaRPr lang="en-US"/>
           </a:p>
@@ -4468,7 +4468,7 @@
           <a:p>
             <a:fld id="{5BCAD085-E8A6-8845-BD4E-CB4CCA059FC4}" type="datetimeFigureOut">
               <a:rPr lang="en-US" smtClean="0"/>
-              <a:t>7/14/2025</a:t>
+              <a:t>9/2/2025</a:t>
             </a:fld>
             <a:endParaRPr lang="en-US"/>
           </a:p>
@@ -4586,7 +4586,7 @@
           <a:p>
             <a:fld id="{5BCAD085-E8A6-8845-BD4E-CB4CCA059FC4}" type="datetimeFigureOut">
               <a:rPr lang="en-US" smtClean="0"/>
-              <a:t>7/14/2025</a:t>
+              <a:t>9/2/2025</a:t>
             </a:fld>
             <a:endParaRPr lang="en-US"/>
           </a:p>
@@ -4681,7 +4681,7 @@
           <a:p>
             <a:fld id="{5BCAD085-E8A6-8845-BD4E-CB4CCA059FC4}" type="datetimeFigureOut">
               <a:rPr lang="en-US" smtClean="0"/>
-              <a:t>7/14/2025</a:t>
+              <a:t>9/2/2025</a:t>
             </a:fld>
             <a:endParaRPr lang="en-US"/>
           </a:p>
@@ -4964,7 +4964,7 @@
           <a:p>
             <a:fld id="{5BCAD085-E8A6-8845-BD4E-CB4CCA059FC4}" type="datetimeFigureOut">
               <a:rPr lang="en-US" smtClean="0"/>
-              <a:t>7/14/2025</a:t>
+              <a:t>9/2/2025</a:t>
             </a:fld>
             <a:endParaRPr lang="en-US"/>
           </a:p>
@@ -5255,7 +5255,7 @@
           <a:p>
             <a:fld id="{5BCAD085-E8A6-8845-BD4E-CB4CCA059FC4}" type="datetimeFigureOut">
               <a:rPr lang="en-US" smtClean="0"/>
-              <a:t>7/14/2025</a:t>
+              <a:t>9/2/2025</a:t>
             </a:fld>
             <a:endParaRPr lang="en-US"/>
           </a:p>
@@ -5812,7 +5812,7 @@
           <a:p>
             <a:fld id="{5BCAD085-E8A6-8845-BD4E-CB4CCA059FC4}" type="datetimeFigureOut">
               <a:rPr lang="en-US" smtClean="0"/>
-              <a:t>7/14/2025</a:t>
+              <a:t>9/2/2025</a:t>
             </a:fld>
             <a:endParaRPr lang="en-US"/>
           </a:p>
@@ -6417,7 +6417,11 @@
             </a:r>
             <a:r>
               <a:rPr lang="en-US" dirty="0"/>
-              <a:t> Harsha</a:t>
+              <a:t> </a:t>
+            </a:r>
+            <a:r>
+              <a:rPr lang="en-US" dirty="0" err="1"/>
+              <a:t>harsha</a:t>
             </a:r>
             <a:endParaRPr dirty="0"/>
           </a:p>
@@ -7014,13 +7018,13 @@
   <p:clrMapOvr>
     <a:masterClrMapping/>
   </p:clrMapOvr>
-  <mc:AlternateContent xmlns:mc="http://schemas.openxmlformats.org/markup-compatibility/2006">
-    <mc:Choice xmlns:p14="http://schemas.microsoft.com/office/powerpoint/2010/main" Requires="p14">
+  <mc:AlternateContent xmlns:mc="http://schemas.openxmlformats.org/markup-compatibility/2006" xmlns:p14="http://schemas.microsoft.com/office/powerpoint/2010/main">
+    <mc:Choice Requires="p14">
       <p:transition spd="med" p14:dur="700">
         <p:fade/>
       </p:transition>
     </mc:Choice>
-    <mc:Fallback>
+    <mc:Fallback xmlns="">
       <p:transition spd="med">
         <p:fade/>
       </p:transition>

</xml_diff>